<commit_message>
Adição das Consultas nos Slides
</commit_message>
<xml_diff>
--- a/Monamu_Slides.pptx
+++ b/Monamu_Slides.pptx
@@ -18,25 +18,29 @@
     <p:sldId id="266" r:id="rId16"/>
     <p:sldId id="267" r:id="rId17"/>
     <p:sldId id="268" r:id="rId18"/>
+    <p:sldId id="269" r:id="rId19"/>
+    <p:sldId id="270" r:id="rId20"/>
+    <p:sldId id="271" r:id="rId21"/>
+    <p:sldId id="272" r:id="rId22"/>
   </p:sldIdLst>
   <p:sldSz cx="18288000" cy="10287000"/>
   <p:notesSz cx="6858000" cy="9144000"/>
   <p:embeddedFontLst>
     <p:embeddedFont>
       <p:font typeface="Open Sans Bold" charset="1" panose="020B0806030504020204"/>
-      <p:regular r:id="rId19"/>
+      <p:regular r:id="rId23"/>
     </p:embeddedFont>
     <p:embeddedFont>
       <p:font typeface="Open Sans" charset="1" panose="020B0606030504020204"/>
-      <p:regular r:id="rId20"/>
+      <p:regular r:id="rId24"/>
     </p:embeddedFont>
     <p:embeddedFont>
       <p:font typeface="Bree Serif" charset="1" panose="02000503040000020004"/>
-      <p:regular r:id="rId21"/>
+      <p:regular r:id="rId25"/>
     </p:embeddedFont>
     <p:embeddedFont>
       <p:font typeface="Arimo Bold" charset="1" panose="020B0704020202020204"/>
-      <p:regular r:id="rId22"/>
+      <p:regular r:id="rId26"/>
     </p:embeddedFont>
   </p:embeddedFontLst>
   <p:defaultTextStyle>
@@ -4280,6 +4284,986 @@
 </p:sld>
 </file>
 
+<file path=ppt/slides/slide14.xml><?xml version="1.0" encoding="utf-8"?>
+<p:sld xmlns:p="http://schemas.openxmlformats.org/presentationml/2006/main" xmlns:a="http://schemas.openxmlformats.org/drawingml/2006/main" xmlns:r="http://schemas.openxmlformats.org/officeDocument/2006/relationships">
+  <p:cSld>
+    <p:bg>
+      <p:bgPr>
+        <a:solidFill>
+          <a:srgbClr val="569076"/>
+        </a:solidFill>
+      </p:bgPr>
+    </p:bg>
+    <p:spTree>
+      <p:nvGrpSpPr>
+        <p:cNvPr id="1" name=""/>
+        <p:cNvGrpSpPr/>
+        <p:nvPr/>
+      </p:nvGrpSpPr>
+      <p:grpSpPr>
+        <a:xfrm>
+          <a:off x="0" y="0"/>
+          <a:ext cx="0" cy="0"/>
+          <a:chOff x="0" y="0"/>
+          <a:chExt cx="0" cy="0"/>
+        </a:xfrm>
+      </p:grpSpPr>
+      <p:sp>
+        <p:nvSpPr>
+          <p:cNvPr name="AutoShape 2" id="2"/>
+          <p:cNvSpPr/>
+          <p:nvPr/>
+        </p:nvSpPr>
+        <p:spPr>
+          <a:xfrm>
+            <a:off x="1028700" y="1969856"/>
+            <a:ext cx="16230600" cy="0"/>
+          </a:xfrm>
+          <a:prstGeom prst="line">
+            <a:avLst/>
+          </a:prstGeom>
+          <a:ln cap="flat" w="9525">
+            <a:solidFill>
+              <a:srgbClr val="000000"/>
+            </a:solidFill>
+            <a:prstDash val="solid"/>
+            <a:headEnd type="none" len="sm" w="sm"/>
+            <a:tailEnd type="none" len="sm" w="sm"/>
+          </a:ln>
+        </p:spPr>
+      </p:sp>
+      <p:sp>
+        <p:nvSpPr>
+          <p:cNvPr name="Freeform 3" id="3"/>
+          <p:cNvSpPr/>
+          <p:nvPr/>
+        </p:nvSpPr>
+        <p:spPr>
+          <a:xfrm flipH="false" flipV="false" rot="0">
+            <a:off x="2789295" y="103619"/>
+            <a:ext cx="800785" cy="1866237"/>
+          </a:xfrm>
+          <a:custGeom>
+            <a:avLst/>
+            <a:gdLst/>
+            <a:ahLst/>
+            <a:cxnLst/>
+            <a:rect r="r" b="b" t="t" l="l"/>
+            <a:pathLst>
+              <a:path h="1866237" w="800785">
+                <a:moveTo>
+                  <a:pt x="0" y="0"/>
+                </a:moveTo>
+                <a:lnTo>
+                  <a:pt x="800785" y="0"/>
+                </a:lnTo>
+                <a:lnTo>
+                  <a:pt x="800785" y="1866237"/>
+                </a:lnTo>
+                <a:lnTo>
+                  <a:pt x="0" y="1866237"/>
+                </a:lnTo>
+                <a:lnTo>
+                  <a:pt x="0" y="0"/>
+                </a:lnTo>
+                <a:close/>
+              </a:path>
+            </a:pathLst>
+          </a:custGeom>
+          <a:blipFill>
+            <a:blip r:embed="rId2">
+              <a:extLst>
+                <a:ext uri="{96DAC541-7B7A-43D3-8B79-37D633B846F1}">
+                  <asvg:svgBlip xmlns:asvg="http://schemas.microsoft.com/office/drawing/2016/SVG/main" r:embed="rId3"/>
+                </a:ext>
+              </a:extLst>
+            </a:blip>
+            <a:stretch>
+              <a:fillRect l="0" t="0" r="0" b="0"/>
+            </a:stretch>
+          </a:blipFill>
+        </p:spPr>
+      </p:sp>
+      <p:sp>
+        <p:nvSpPr>
+          <p:cNvPr name="Freeform 4" id="4"/>
+          <p:cNvSpPr/>
+          <p:nvPr/>
+        </p:nvSpPr>
+        <p:spPr>
+          <a:xfrm flipH="false" flipV="false" rot="0">
+            <a:off x="546529" y="3927728"/>
+            <a:ext cx="17194942" cy="5738102"/>
+          </a:xfrm>
+          <a:custGeom>
+            <a:avLst/>
+            <a:gdLst/>
+            <a:ahLst/>
+            <a:cxnLst/>
+            <a:rect r="r" b="b" t="t" l="l"/>
+            <a:pathLst>
+              <a:path h="5738102" w="17194942">
+                <a:moveTo>
+                  <a:pt x="0" y="0"/>
+                </a:moveTo>
+                <a:lnTo>
+                  <a:pt x="17194942" y="0"/>
+                </a:lnTo>
+                <a:lnTo>
+                  <a:pt x="17194942" y="5738102"/>
+                </a:lnTo>
+                <a:lnTo>
+                  <a:pt x="0" y="5738102"/>
+                </a:lnTo>
+                <a:lnTo>
+                  <a:pt x="0" y="0"/>
+                </a:lnTo>
+                <a:close/>
+              </a:path>
+            </a:pathLst>
+          </a:custGeom>
+          <a:blipFill>
+            <a:blip r:embed="rId4"/>
+            <a:stretch>
+              <a:fillRect l="0" t="-1885" r="0" b="0"/>
+            </a:stretch>
+          </a:blipFill>
+        </p:spPr>
+      </p:sp>
+      <p:sp>
+        <p:nvSpPr>
+          <p:cNvPr name="TextBox 5" id="5"/>
+          <p:cNvSpPr txBox="true"/>
+          <p:nvPr/>
+        </p:nvSpPr>
+        <p:spPr>
+          <a:xfrm rot="0">
+            <a:off x="2387270" y="528002"/>
+            <a:ext cx="7064586" cy="896620"/>
+          </a:xfrm>
+          <a:prstGeom prst="rect">
+            <a:avLst/>
+          </a:prstGeom>
+        </p:spPr>
+        <p:txBody>
+          <a:bodyPr anchor="t" rtlCol="false" tIns="0" lIns="0" bIns="0" rIns="0">
+            <a:spAutoFit/>
+          </a:bodyPr>
+          <a:lstStyle/>
+          <a:p>
+            <a:pPr algn="ctr">
+              <a:lnSpc>
+                <a:spcPts val="7279"/>
+              </a:lnSpc>
+            </a:pPr>
+            <a:r>
+              <a:rPr lang="en-US" sz="5199">
+                <a:solidFill>
+                  <a:srgbClr val="000000"/>
+                </a:solidFill>
+                <a:latin typeface="Bree Serif"/>
+                <a:ea typeface="Bree Serif"/>
+                <a:cs typeface="Bree Serif"/>
+                <a:sym typeface="Bree Serif"/>
+              </a:rPr>
+              <a:t>Consultas</a:t>
+            </a:r>
+          </a:p>
+        </p:txBody>
+      </p:sp>
+      <p:sp>
+        <p:nvSpPr>
+          <p:cNvPr name="TextBox 6" id="6"/>
+          <p:cNvSpPr txBox="true"/>
+          <p:nvPr/>
+        </p:nvSpPr>
+        <p:spPr>
+          <a:xfrm rot="0">
+            <a:off x="2886981" y="2130096"/>
+            <a:ext cx="12514039" cy="1581150"/>
+          </a:xfrm>
+          <a:prstGeom prst="rect">
+            <a:avLst/>
+          </a:prstGeom>
+        </p:spPr>
+        <p:txBody>
+          <a:bodyPr anchor="t" rtlCol="false" tIns="0" lIns="0" bIns="0" rIns="0">
+            <a:spAutoFit/>
+          </a:bodyPr>
+          <a:lstStyle/>
+          <a:p>
+            <a:pPr algn="ctr">
+              <a:lnSpc>
+                <a:spcPts val="4200"/>
+              </a:lnSpc>
+              <a:spcBef>
+                <a:spcPct val="0"/>
+              </a:spcBef>
+            </a:pPr>
+            <a:r>
+              <a:rPr lang="en-US" sz="3000">
+                <a:solidFill>
+                  <a:srgbClr val="000000"/>
+                </a:solidFill>
+                <a:latin typeface="Bree Serif"/>
+                <a:ea typeface="Bree Serif"/>
+                <a:cs typeface="Bree Serif"/>
+                <a:sym typeface="Bree Serif"/>
+              </a:rPr>
+              <a:t>Li</a:t>
+            </a:r>
+            <a:r>
+              <a:rPr lang="en-US" sz="3000">
+                <a:solidFill>
+                  <a:srgbClr val="000000"/>
+                </a:solidFill>
+                <a:latin typeface="Bree Serif"/>
+                <a:ea typeface="Bree Serif"/>
+                <a:cs typeface="Bree Serif"/>
+                <a:sym typeface="Bree Serif"/>
+              </a:rPr>
+              <a:t>ste o nome do produto, categoria, tamanho, preço de venda e quantidade em estoque de todos os produtos disponíveis para venda. Ordene os resultados por nome do produto.</a:t>
+            </a:r>
+          </a:p>
+        </p:txBody>
+      </p:sp>
+    </p:spTree>
+  </p:cSld>
+  <p:clrMapOvr>
+    <a:masterClrMapping/>
+  </p:clrMapOvr>
+</p:sld>
+</file>
+
+<file path=ppt/slides/slide15.xml><?xml version="1.0" encoding="utf-8"?>
+<p:sld xmlns:p="http://schemas.openxmlformats.org/presentationml/2006/main" xmlns:a="http://schemas.openxmlformats.org/drawingml/2006/main" xmlns:r="http://schemas.openxmlformats.org/officeDocument/2006/relationships">
+  <p:cSld>
+    <p:bg>
+      <p:bgPr>
+        <a:solidFill>
+          <a:srgbClr val="569076"/>
+        </a:solidFill>
+      </p:bgPr>
+    </p:bg>
+    <p:spTree>
+      <p:nvGrpSpPr>
+        <p:cNvPr id="1" name=""/>
+        <p:cNvGrpSpPr/>
+        <p:nvPr/>
+      </p:nvGrpSpPr>
+      <p:grpSpPr>
+        <a:xfrm>
+          <a:off x="0" y="0"/>
+          <a:ext cx="0" cy="0"/>
+          <a:chOff x="0" y="0"/>
+          <a:chExt cx="0" cy="0"/>
+        </a:xfrm>
+      </p:grpSpPr>
+      <p:sp>
+        <p:nvSpPr>
+          <p:cNvPr name="AutoShape 2" id="2"/>
+          <p:cNvSpPr/>
+          <p:nvPr/>
+        </p:nvSpPr>
+        <p:spPr>
+          <a:xfrm>
+            <a:off x="1028700" y="1969856"/>
+            <a:ext cx="16230600" cy="0"/>
+          </a:xfrm>
+          <a:prstGeom prst="line">
+            <a:avLst/>
+          </a:prstGeom>
+          <a:ln cap="flat" w="9525">
+            <a:solidFill>
+              <a:srgbClr val="000000"/>
+            </a:solidFill>
+            <a:prstDash val="solid"/>
+            <a:headEnd type="none" len="sm" w="sm"/>
+            <a:tailEnd type="none" len="sm" w="sm"/>
+          </a:ln>
+        </p:spPr>
+      </p:sp>
+      <p:sp>
+        <p:nvSpPr>
+          <p:cNvPr name="Freeform 3" id="3"/>
+          <p:cNvSpPr/>
+          <p:nvPr/>
+        </p:nvSpPr>
+        <p:spPr>
+          <a:xfrm flipH="false" flipV="false" rot="0">
+            <a:off x="2789295" y="103619"/>
+            <a:ext cx="800785" cy="1866237"/>
+          </a:xfrm>
+          <a:custGeom>
+            <a:avLst/>
+            <a:gdLst/>
+            <a:ahLst/>
+            <a:cxnLst/>
+            <a:rect r="r" b="b" t="t" l="l"/>
+            <a:pathLst>
+              <a:path h="1866237" w="800785">
+                <a:moveTo>
+                  <a:pt x="0" y="0"/>
+                </a:moveTo>
+                <a:lnTo>
+                  <a:pt x="800785" y="0"/>
+                </a:lnTo>
+                <a:lnTo>
+                  <a:pt x="800785" y="1866237"/>
+                </a:lnTo>
+                <a:lnTo>
+                  <a:pt x="0" y="1866237"/>
+                </a:lnTo>
+                <a:lnTo>
+                  <a:pt x="0" y="0"/>
+                </a:lnTo>
+                <a:close/>
+              </a:path>
+            </a:pathLst>
+          </a:custGeom>
+          <a:blipFill>
+            <a:blip r:embed="rId2">
+              <a:extLst>
+                <a:ext uri="{96DAC541-7B7A-43D3-8B79-37D633B846F1}">
+                  <asvg:svgBlip xmlns:asvg="http://schemas.microsoft.com/office/drawing/2016/SVG/main" r:embed="rId3"/>
+                </a:ext>
+              </a:extLst>
+            </a:blip>
+            <a:stretch>
+              <a:fillRect l="0" t="0" r="0" b="0"/>
+            </a:stretch>
+          </a:blipFill>
+        </p:spPr>
+      </p:sp>
+      <p:sp>
+        <p:nvSpPr>
+          <p:cNvPr name="Freeform 4" id="4"/>
+          <p:cNvSpPr/>
+          <p:nvPr/>
+        </p:nvSpPr>
+        <p:spPr>
+          <a:xfrm flipH="false" flipV="false" rot="0">
+            <a:off x="1028700" y="4442577"/>
+            <a:ext cx="16230600" cy="3428714"/>
+          </a:xfrm>
+          <a:custGeom>
+            <a:avLst/>
+            <a:gdLst/>
+            <a:ahLst/>
+            <a:cxnLst/>
+            <a:rect r="r" b="b" t="t" l="l"/>
+            <a:pathLst>
+              <a:path h="3428714" w="16230600">
+                <a:moveTo>
+                  <a:pt x="0" y="0"/>
+                </a:moveTo>
+                <a:lnTo>
+                  <a:pt x="16230600" y="0"/>
+                </a:lnTo>
+                <a:lnTo>
+                  <a:pt x="16230600" y="3428715"/>
+                </a:lnTo>
+                <a:lnTo>
+                  <a:pt x="0" y="3428715"/>
+                </a:lnTo>
+                <a:lnTo>
+                  <a:pt x="0" y="0"/>
+                </a:lnTo>
+                <a:close/>
+              </a:path>
+            </a:pathLst>
+          </a:custGeom>
+          <a:blipFill>
+            <a:blip r:embed="rId4"/>
+            <a:stretch>
+              <a:fillRect l="0" t="0" r="0" b="0"/>
+            </a:stretch>
+          </a:blipFill>
+        </p:spPr>
+      </p:sp>
+      <p:sp>
+        <p:nvSpPr>
+          <p:cNvPr name="TextBox 5" id="5"/>
+          <p:cNvSpPr txBox="true"/>
+          <p:nvPr/>
+        </p:nvSpPr>
+        <p:spPr>
+          <a:xfrm rot="0">
+            <a:off x="2387270" y="528002"/>
+            <a:ext cx="7064586" cy="896620"/>
+          </a:xfrm>
+          <a:prstGeom prst="rect">
+            <a:avLst/>
+          </a:prstGeom>
+        </p:spPr>
+        <p:txBody>
+          <a:bodyPr anchor="t" rtlCol="false" tIns="0" lIns="0" bIns="0" rIns="0">
+            <a:spAutoFit/>
+          </a:bodyPr>
+          <a:lstStyle/>
+          <a:p>
+            <a:pPr algn="ctr">
+              <a:lnSpc>
+                <a:spcPts val="7279"/>
+              </a:lnSpc>
+            </a:pPr>
+            <a:r>
+              <a:rPr lang="en-US" sz="5199">
+                <a:solidFill>
+                  <a:srgbClr val="000000"/>
+                </a:solidFill>
+                <a:latin typeface="Bree Serif"/>
+                <a:ea typeface="Bree Serif"/>
+                <a:cs typeface="Bree Serif"/>
+                <a:sym typeface="Bree Serif"/>
+              </a:rPr>
+              <a:t>Consultas</a:t>
+            </a:r>
+          </a:p>
+        </p:txBody>
+      </p:sp>
+      <p:sp>
+        <p:nvSpPr>
+          <p:cNvPr name="TextBox 6" id="6"/>
+          <p:cNvSpPr txBox="true"/>
+          <p:nvPr/>
+        </p:nvSpPr>
+        <p:spPr>
+          <a:xfrm rot="0">
+            <a:off x="2439927" y="2318502"/>
+            <a:ext cx="13408146" cy="1581150"/>
+          </a:xfrm>
+          <a:prstGeom prst="rect">
+            <a:avLst/>
+          </a:prstGeom>
+        </p:spPr>
+        <p:txBody>
+          <a:bodyPr anchor="t" rtlCol="false" tIns="0" lIns="0" bIns="0" rIns="0">
+            <a:spAutoFit/>
+          </a:bodyPr>
+          <a:lstStyle/>
+          <a:p>
+            <a:pPr algn="ctr">
+              <a:lnSpc>
+                <a:spcPts val="4200"/>
+              </a:lnSpc>
+              <a:spcBef>
+                <a:spcPct val="0"/>
+              </a:spcBef>
+            </a:pPr>
+            <a:r>
+              <a:rPr lang="en-US" sz="3000">
+                <a:solidFill>
+                  <a:srgbClr val="000000"/>
+                </a:solidFill>
+                <a:latin typeface="Bree Serif"/>
+                <a:ea typeface="Bree Serif"/>
+                <a:cs typeface="Bree Serif"/>
+                <a:sym typeface="Bree Serif"/>
+              </a:rPr>
+              <a:t>Liste o nome do cliente, a data da compra, os produtos comprados e o valor total de cada compra. Exiba apenas as compras do cliente selecionado. Ordene pela data da compra, da mais recente para a mais antiga.</a:t>
+            </a:r>
+          </a:p>
+        </p:txBody>
+      </p:sp>
+    </p:spTree>
+  </p:cSld>
+  <p:clrMapOvr>
+    <a:masterClrMapping/>
+  </p:clrMapOvr>
+</p:sld>
+</file>
+
+<file path=ppt/slides/slide16.xml><?xml version="1.0" encoding="utf-8"?>
+<p:sld xmlns:p="http://schemas.openxmlformats.org/presentationml/2006/main" xmlns:a="http://schemas.openxmlformats.org/drawingml/2006/main" xmlns:r="http://schemas.openxmlformats.org/officeDocument/2006/relationships">
+  <p:cSld>
+    <p:bg>
+      <p:bgPr>
+        <a:solidFill>
+          <a:srgbClr val="569076"/>
+        </a:solidFill>
+      </p:bgPr>
+    </p:bg>
+    <p:spTree>
+      <p:nvGrpSpPr>
+        <p:cNvPr id="1" name=""/>
+        <p:cNvGrpSpPr/>
+        <p:nvPr/>
+      </p:nvGrpSpPr>
+      <p:grpSpPr>
+        <a:xfrm>
+          <a:off x="0" y="0"/>
+          <a:ext cx="0" cy="0"/>
+          <a:chOff x="0" y="0"/>
+          <a:chExt cx="0" cy="0"/>
+        </a:xfrm>
+      </p:grpSpPr>
+      <p:sp>
+        <p:nvSpPr>
+          <p:cNvPr name="AutoShape 2" id="2"/>
+          <p:cNvSpPr/>
+          <p:nvPr/>
+        </p:nvSpPr>
+        <p:spPr>
+          <a:xfrm>
+            <a:off x="1028700" y="1969856"/>
+            <a:ext cx="16230600" cy="0"/>
+          </a:xfrm>
+          <a:prstGeom prst="line">
+            <a:avLst/>
+          </a:prstGeom>
+          <a:ln cap="flat" w="9525">
+            <a:solidFill>
+              <a:srgbClr val="000000"/>
+            </a:solidFill>
+            <a:prstDash val="solid"/>
+            <a:headEnd type="none" len="sm" w="sm"/>
+            <a:tailEnd type="none" len="sm" w="sm"/>
+          </a:ln>
+        </p:spPr>
+      </p:sp>
+      <p:sp>
+        <p:nvSpPr>
+          <p:cNvPr name="Freeform 3" id="3"/>
+          <p:cNvSpPr/>
+          <p:nvPr/>
+        </p:nvSpPr>
+        <p:spPr>
+          <a:xfrm flipH="false" flipV="false" rot="0">
+            <a:off x="2789295" y="103619"/>
+            <a:ext cx="800785" cy="1866237"/>
+          </a:xfrm>
+          <a:custGeom>
+            <a:avLst/>
+            <a:gdLst/>
+            <a:ahLst/>
+            <a:cxnLst/>
+            <a:rect r="r" b="b" t="t" l="l"/>
+            <a:pathLst>
+              <a:path h="1866237" w="800785">
+                <a:moveTo>
+                  <a:pt x="0" y="0"/>
+                </a:moveTo>
+                <a:lnTo>
+                  <a:pt x="800785" y="0"/>
+                </a:lnTo>
+                <a:lnTo>
+                  <a:pt x="800785" y="1866237"/>
+                </a:lnTo>
+                <a:lnTo>
+                  <a:pt x="0" y="1866237"/>
+                </a:lnTo>
+                <a:lnTo>
+                  <a:pt x="0" y="0"/>
+                </a:lnTo>
+                <a:close/>
+              </a:path>
+            </a:pathLst>
+          </a:custGeom>
+          <a:blipFill>
+            <a:blip r:embed="rId2">
+              <a:extLst>
+                <a:ext uri="{96DAC541-7B7A-43D3-8B79-37D633B846F1}">
+                  <asvg:svgBlip xmlns:asvg="http://schemas.microsoft.com/office/drawing/2016/SVG/main" r:embed="rId3"/>
+                </a:ext>
+              </a:extLst>
+            </a:blip>
+            <a:stretch>
+              <a:fillRect l="0" t="0" r="0" b="0"/>
+            </a:stretch>
+          </a:blipFill>
+        </p:spPr>
+      </p:sp>
+      <p:sp>
+        <p:nvSpPr>
+          <p:cNvPr name="Freeform 4" id="4"/>
+          <p:cNvSpPr/>
+          <p:nvPr/>
+        </p:nvSpPr>
+        <p:spPr>
+          <a:xfrm flipH="false" flipV="false" rot="0">
+            <a:off x="1028700" y="4299702"/>
+            <a:ext cx="16230600" cy="4057650"/>
+          </a:xfrm>
+          <a:custGeom>
+            <a:avLst/>
+            <a:gdLst/>
+            <a:ahLst/>
+            <a:cxnLst/>
+            <a:rect r="r" b="b" t="t" l="l"/>
+            <a:pathLst>
+              <a:path h="4057650" w="16230600">
+                <a:moveTo>
+                  <a:pt x="0" y="0"/>
+                </a:moveTo>
+                <a:lnTo>
+                  <a:pt x="16230600" y="0"/>
+                </a:lnTo>
+                <a:lnTo>
+                  <a:pt x="16230600" y="4057650"/>
+                </a:lnTo>
+                <a:lnTo>
+                  <a:pt x="0" y="4057650"/>
+                </a:lnTo>
+                <a:lnTo>
+                  <a:pt x="0" y="0"/>
+                </a:lnTo>
+                <a:close/>
+              </a:path>
+            </a:pathLst>
+          </a:custGeom>
+          <a:blipFill>
+            <a:blip r:embed="rId4"/>
+            <a:stretch>
+              <a:fillRect l="0" t="0" r="0" b="0"/>
+            </a:stretch>
+          </a:blipFill>
+        </p:spPr>
+      </p:sp>
+      <p:sp>
+        <p:nvSpPr>
+          <p:cNvPr name="TextBox 5" id="5"/>
+          <p:cNvSpPr txBox="true"/>
+          <p:nvPr/>
+        </p:nvSpPr>
+        <p:spPr>
+          <a:xfrm rot="0">
+            <a:off x="2387270" y="528002"/>
+            <a:ext cx="7064586" cy="896620"/>
+          </a:xfrm>
+          <a:prstGeom prst="rect">
+            <a:avLst/>
+          </a:prstGeom>
+        </p:spPr>
+        <p:txBody>
+          <a:bodyPr anchor="t" rtlCol="false" tIns="0" lIns="0" bIns="0" rIns="0">
+            <a:spAutoFit/>
+          </a:bodyPr>
+          <a:lstStyle/>
+          <a:p>
+            <a:pPr algn="ctr">
+              <a:lnSpc>
+                <a:spcPts val="7279"/>
+              </a:lnSpc>
+            </a:pPr>
+            <a:r>
+              <a:rPr lang="en-US" sz="5199">
+                <a:solidFill>
+                  <a:srgbClr val="000000"/>
+                </a:solidFill>
+                <a:latin typeface="Bree Serif"/>
+                <a:ea typeface="Bree Serif"/>
+                <a:cs typeface="Bree Serif"/>
+                <a:sym typeface="Bree Serif"/>
+              </a:rPr>
+              <a:t>Consultas</a:t>
+            </a:r>
+          </a:p>
+        </p:txBody>
+      </p:sp>
+      <p:sp>
+        <p:nvSpPr>
+          <p:cNvPr name="TextBox 6" id="6"/>
+          <p:cNvSpPr txBox="true"/>
+          <p:nvPr/>
+        </p:nvSpPr>
+        <p:spPr>
+          <a:xfrm rot="0">
+            <a:off x="2439927" y="2318502"/>
+            <a:ext cx="13408146" cy="1581150"/>
+          </a:xfrm>
+          <a:prstGeom prst="rect">
+            <a:avLst/>
+          </a:prstGeom>
+        </p:spPr>
+        <p:txBody>
+          <a:bodyPr anchor="t" rtlCol="false" tIns="0" lIns="0" bIns="0" rIns="0">
+            <a:spAutoFit/>
+          </a:bodyPr>
+          <a:lstStyle/>
+          <a:p>
+            <a:pPr algn="ctr">
+              <a:lnSpc>
+                <a:spcPts val="4200"/>
+              </a:lnSpc>
+              <a:spcBef>
+                <a:spcPct val="0"/>
+              </a:spcBef>
+            </a:pPr>
+            <a:r>
+              <a:rPr lang="en-US" sz="3000">
+                <a:solidFill>
+                  <a:srgbClr val="000000"/>
+                </a:solidFill>
+                <a:latin typeface="Bree Serif"/>
+                <a:ea typeface="Bree Serif"/>
+                <a:cs typeface="Bree Serif"/>
+                <a:sym typeface="Bree Serif"/>
+              </a:rPr>
+              <a:t>Liste o nome do funcionário, a data da venda, os produtos vendidos e o valor total de cada venda realizada em um período definido. Ordene por nome do funcionário e, dentro do funcionário, por data da venda.</a:t>
+            </a:r>
+          </a:p>
+        </p:txBody>
+      </p:sp>
+    </p:spTree>
+  </p:cSld>
+  <p:clrMapOvr>
+    <a:masterClrMapping/>
+  </p:clrMapOvr>
+</p:sld>
+</file>
+
+<file path=ppt/slides/slide17.xml><?xml version="1.0" encoding="utf-8"?>
+<p:sld xmlns:p="http://schemas.openxmlformats.org/presentationml/2006/main" xmlns:a="http://schemas.openxmlformats.org/drawingml/2006/main" xmlns:r="http://schemas.openxmlformats.org/officeDocument/2006/relationships">
+  <p:cSld>
+    <p:bg>
+      <p:bgPr>
+        <a:solidFill>
+          <a:srgbClr val="569076"/>
+        </a:solidFill>
+      </p:bgPr>
+    </p:bg>
+    <p:spTree>
+      <p:nvGrpSpPr>
+        <p:cNvPr id="1" name=""/>
+        <p:cNvGrpSpPr/>
+        <p:nvPr/>
+      </p:nvGrpSpPr>
+      <p:grpSpPr>
+        <a:xfrm>
+          <a:off x="0" y="0"/>
+          <a:ext cx="0" cy="0"/>
+          <a:chOff x="0" y="0"/>
+          <a:chExt cx="0" cy="0"/>
+        </a:xfrm>
+      </p:grpSpPr>
+      <p:sp>
+        <p:nvSpPr>
+          <p:cNvPr name="AutoShape 2" id="2"/>
+          <p:cNvSpPr/>
+          <p:nvPr/>
+        </p:nvSpPr>
+        <p:spPr>
+          <a:xfrm>
+            <a:off x="1028700" y="1969856"/>
+            <a:ext cx="16230600" cy="0"/>
+          </a:xfrm>
+          <a:prstGeom prst="line">
+            <a:avLst/>
+          </a:prstGeom>
+          <a:ln cap="flat" w="9525">
+            <a:solidFill>
+              <a:srgbClr val="000000"/>
+            </a:solidFill>
+            <a:prstDash val="solid"/>
+            <a:headEnd type="none" len="sm" w="sm"/>
+            <a:tailEnd type="none" len="sm" w="sm"/>
+          </a:ln>
+        </p:spPr>
+      </p:sp>
+      <p:sp>
+        <p:nvSpPr>
+          <p:cNvPr name="Freeform 3" id="3"/>
+          <p:cNvSpPr/>
+          <p:nvPr/>
+        </p:nvSpPr>
+        <p:spPr>
+          <a:xfrm flipH="false" flipV="false" rot="0">
+            <a:off x="2789295" y="103619"/>
+            <a:ext cx="800785" cy="1866237"/>
+          </a:xfrm>
+          <a:custGeom>
+            <a:avLst/>
+            <a:gdLst/>
+            <a:ahLst/>
+            <a:cxnLst/>
+            <a:rect r="r" b="b" t="t" l="l"/>
+            <a:pathLst>
+              <a:path h="1866237" w="800785">
+                <a:moveTo>
+                  <a:pt x="0" y="0"/>
+                </a:moveTo>
+                <a:lnTo>
+                  <a:pt x="800785" y="0"/>
+                </a:lnTo>
+                <a:lnTo>
+                  <a:pt x="800785" y="1866237"/>
+                </a:lnTo>
+                <a:lnTo>
+                  <a:pt x="0" y="1866237"/>
+                </a:lnTo>
+                <a:lnTo>
+                  <a:pt x="0" y="0"/>
+                </a:lnTo>
+                <a:close/>
+              </a:path>
+            </a:pathLst>
+          </a:custGeom>
+          <a:blipFill>
+            <a:blip r:embed="rId2">
+              <a:extLst>
+                <a:ext uri="{96DAC541-7B7A-43D3-8B79-37D633B846F1}">
+                  <asvg:svgBlip xmlns:asvg="http://schemas.microsoft.com/office/drawing/2016/SVG/main" r:embed="rId3"/>
+                </a:ext>
+              </a:extLst>
+            </a:blip>
+            <a:stretch>
+              <a:fillRect l="0" t="0" r="0" b="0"/>
+            </a:stretch>
+          </a:blipFill>
+        </p:spPr>
+      </p:sp>
+      <p:sp>
+        <p:nvSpPr>
+          <p:cNvPr name="Freeform 4" id="4"/>
+          <p:cNvSpPr/>
+          <p:nvPr/>
+        </p:nvSpPr>
+        <p:spPr>
+          <a:xfrm flipH="false" flipV="false" rot="0">
+            <a:off x="1028700" y="4442577"/>
+            <a:ext cx="16230600" cy="3124391"/>
+          </a:xfrm>
+          <a:custGeom>
+            <a:avLst/>
+            <a:gdLst/>
+            <a:ahLst/>
+            <a:cxnLst/>
+            <a:rect r="r" b="b" t="t" l="l"/>
+            <a:pathLst>
+              <a:path h="3124391" w="16230600">
+                <a:moveTo>
+                  <a:pt x="0" y="0"/>
+                </a:moveTo>
+                <a:lnTo>
+                  <a:pt x="16230600" y="0"/>
+                </a:lnTo>
+                <a:lnTo>
+                  <a:pt x="16230600" y="3124391"/>
+                </a:lnTo>
+                <a:lnTo>
+                  <a:pt x="0" y="3124391"/>
+                </a:lnTo>
+                <a:lnTo>
+                  <a:pt x="0" y="0"/>
+                </a:lnTo>
+                <a:close/>
+              </a:path>
+            </a:pathLst>
+          </a:custGeom>
+          <a:blipFill>
+            <a:blip r:embed="rId4"/>
+            <a:stretch>
+              <a:fillRect l="0" t="0" r="0" b="0"/>
+            </a:stretch>
+          </a:blipFill>
+        </p:spPr>
+      </p:sp>
+      <p:sp>
+        <p:nvSpPr>
+          <p:cNvPr name="TextBox 5" id="5"/>
+          <p:cNvSpPr txBox="true"/>
+          <p:nvPr/>
+        </p:nvSpPr>
+        <p:spPr>
+          <a:xfrm rot="0">
+            <a:off x="2387270" y="528002"/>
+            <a:ext cx="7064586" cy="896620"/>
+          </a:xfrm>
+          <a:prstGeom prst="rect">
+            <a:avLst/>
+          </a:prstGeom>
+        </p:spPr>
+        <p:txBody>
+          <a:bodyPr anchor="t" rtlCol="false" tIns="0" lIns="0" bIns="0" rIns="0">
+            <a:spAutoFit/>
+          </a:bodyPr>
+          <a:lstStyle/>
+          <a:p>
+            <a:pPr algn="ctr">
+              <a:lnSpc>
+                <a:spcPts val="7279"/>
+              </a:lnSpc>
+            </a:pPr>
+            <a:r>
+              <a:rPr lang="en-US" sz="5199">
+                <a:solidFill>
+                  <a:srgbClr val="000000"/>
+                </a:solidFill>
+                <a:latin typeface="Bree Serif"/>
+                <a:ea typeface="Bree Serif"/>
+                <a:cs typeface="Bree Serif"/>
+                <a:sym typeface="Bree Serif"/>
+              </a:rPr>
+              <a:t>Consultas</a:t>
+            </a:r>
+          </a:p>
+        </p:txBody>
+      </p:sp>
+      <p:sp>
+        <p:nvSpPr>
+          <p:cNvPr name="TextBox 6" id="6"/>
+          <p:cNvSpPr txBox="true"/>
+          <p:nvPr/>
+        </p:nvSpPr>
+        <p:spPr>
+          <a:xfrm rot="0">
+            <a:off x="2439927" y="2318502"/>
+            <a:ext cx="13408146" cy="1581150"/>
+          </a:xfrm>
+          <a:prstGeom prst="rect">
+            <a:avLst/>
+          </a:prstGeom>
+        </p:spPr>
+        <p:txBody>
+          <a:bodyPr anchor="t" rtlCol="false" tIns="0" lIns="0" bIns="0" rIns="0">
+            <a:spAutoFit/>
+          </a:bodyPr>
+          <a:lstStyle/>
+          <a:p>
+            <a:pPr algn="ctr">
+              <a:lnSpc>
+                <a:spcPts val="4200"/>
+              </a:lnSpc>
+              <a:spcBef>
+                <a:spcPct val="0"/>
+              </a:spcBef>
+            </a:pPr>
+            <a:r>
+              <a:rPr lang="en-US" sz="3000">
+                <a:solidFill>
+                  <a:srgbClr val="000000"/>
+                </a:solidFill>
+                <a:latin typeface="Bree Serif"/>
+                <a:ea typeface="Bree Serif"/>
+                <a:cs typeface="Bree Serif"/>
+                <a:sym typeface="Bree Serif"/>
+              </a:rPr>
+              <a:t>Mo</a:t>
+            </a:r>
+            <a:r>
+              <a:rPr lang="en-US" sz="3000">
+                <a:solidFill>
+                  <a:srgbClr val="000000"/>
+                </a:solidFill>
+                <a:latin typeface="Bree Serif"/>
+                <a:ea typeface="Bree Serif"/>
+                <a:cs typeface="Bree Serif"/>
+                <a:sym typeface="Bree Serif"/>
+              </a:rPr>
+              <a:t>stre, para cada categoria de produto, a quantidade total vendida e o valor total faturado em um período definido. Liste apenas as categorias com vendas registradas e ordene pelo maior valor faturado.</a:t>
+            </a:r>
+          </a:p>
+        </p:txBody>
+      </p:sp>
+    </p:spTree>
+  </p:cSld>
+  <p:clrMapOvr>
+    <a:masterClrMapping/>
+  </p:clrMapOvr>
+</p:sld>
+</file>
+
 <file path=ppt/slides/slide2.xml><?xml version="1.0" encoding="utf-8"?>
 <p:sld xmlns:p="http://schemas.openxmlformats.org/presentationml/2006/main" xmlns:a="http://schemas.openxmlformats.org/drawingml/2006/main" xmlns:r="http://schemas.openxmlformats.org/officeDocument/2006/relationships">
   <p:cSld>

</xml_diff>